<commit_message>
docs: update executive presentation deck with latest edits
</commit_message>
<xml_diff>
--- a/Architectural_Styles_LoRA_Presentation.pptx
+++ b/Architectural_Styles_LoRA_Presentation.pptx
@@ -5,19 +5,19 @@
     <p:sldMasterId id="2147483648" r:id="rId1"/>
   </p:sldMasterIdLst>
   <p:sldIdLst>
-    <p:sldId id="256" r:id="rId7"/>
-    <p:sldId id="257" r:id="rId8"/>
-    <p:sldId id="258" r:id="rId9"/>
-    <p:sldId id="259" r:id="rId10"/>
-    <p:sldId id="260" r:id="rId11"/>
-    <p:sldId id="261" r:id="rId12"/>
-    <p:sldId id="262" r:id="rId13"/>
-    <p:sldId id="263" r:id="rId14"/>
-    <p:sldId id="264" r:id="rId15"/>
-    <p:sldId id="265" r:id="rId16"/>
-    <p:sldId id="266" r:id="rId17"/>
+    <p:sldId id="256" r:id="rId2"/>
+    <p:sldId id="257" r:id="rId3"/>
+    <p:sldId id="258" r:id="rId4"/>
+    <p:sldId id="259" r:id="rId5"/>
+    <p:sldId id="260" r:id="rId6"/>
+    <p:sldId id="261" r:id="rId7"/>
+    <p:sldId id="262" r:id="rId8"/>
+    <p:sldId id="263" r:id="rId9"/>
+    <p:sldId id="264" r:id="rId10"/>
+    <p:sldId id="265" r:id="rId11"/>
+    <p:sldId id="266" r:id="rId12"/>
   </p:sldIdLst>
-  <p:sldSz cx="12191695" cy="6858000" type="screen4x3"/>
+  <p:sldSz cx="12192000" cy="6858000"/>
   <p:notesSz cx="6858000" cy="9144000"/>
   <p:defaultTextStyle>
     <a:defPPr>
@@ -114,6 +114,22 @@
       </a:defRPr>
     </a:lvl9pPr>
   </p:defaultTextStyle>
+  <p:extLst>
+    <p:ext uri="{EFAFB233-063F-42B5-8137-9DF3F51BA10A}">
+      <p15:sldGuideLst xmlns:p15="http://schemas.microsoft.com/office/powerpoint/2012/main">
+        <p15:guide id="1" orient="horz" pos="2160">
+          <p15:clr>
+            <a:srgbClr val="A4A3A4"/>
+          </p15:clr>
+        </p15:guide>
+        <p15:guide id="2" pos="2880">
+          <p15:clr>
+            <a:srgbClr val="A4A3A4"/>
+          </p15:clr>
+        </p15:guide>
+      </p15:sldGuideLst>
+    </p:ext>
+  </p:extLst>
 </p:presentation>
 </file>
 
@@ -155,10 +171,9 @@
           <a:lstStyle/>
           <a:p>
             <a:r>
-              <a:rPr lang="en-US" smtClean="0"/>
+              <a:rPr lang="en-US"/>
               <a:t>Click to edit Master title style</a:t>
             </a:r>
-            <a:endParaRPr lang="en-US"/>
           </a:p>
         </p:txBody>
       </p:sp>
@@ -274,10 +289,9 @@
           </a:lstStyle>
           <a:p>
             <a:r>
-              <a:rPr lang="en-US" smtClean="0"/>
+              <a:rPr lang="en-US"/>
               <a:t>Click to edit Master subtitle style</a:t>
             </a:r>
-            <a:endParaRPr lang="en-US"/>
           </a:p>
         </p:txBody>
       </p:sp>
@@ -298,7 +312,7 @@
           <a:p>
             <a:fld id="{5BCAD085-E8A6-8845-BD4E-CB4CCA059FC4}" type="datetimeFigureOut">
               <a:rPr lang="en-US" smtClean="0"/>
-              <a:t>1/27/13</a:t>
+              <a:t>9/23/2026</a:t>
             </a:fld>
             <a:endParaRPr lang="en-US"/>
           </a:p>
@@ -392,10 +406,9 @@
           <a:lstStyle/>
           <a:p>
             <a:r>
-              <a:rPr lang="en-US" smtClean="0"/>
+              <a:rPr lang="en-US"/>
               <a:t>Click to edit Master title style</a:t>
             </a:r>
-            <a:endParaRPr lang="en-US"/>
           </a:p>
         </p:txBody>
       </p:sp>
@@ -416,38 +429,37 @@
           <a:p>
             <a:pPr lvl="0"/>
             <a:r>
-              <a:rPr lang="en-US" smtClean="0"/>
+              <a:rPr lang="en-US"/>
               <a:t>Click to edit Master text styles</a:t>
             </a:r>
           </a:p>
           <a:p>
             <a:pPr lvl="1"/>
             <a:r>
-              <a:rPr lang="en-US" smtClean="0"/>
+              <a:rPr lang="en-US"/>
               <a:t>Second level</a:t>
             </a:r>
           </a:p>
           <a:p>
             <a:pPr lvl="2"/>
             <a:r>
-              <a:rPr lang="en-US" smtClean="0"/>
+              <a:rPr lang="en-US"/>
               <a:t>Third level</a:t>
             </a:r>
           </a:p>
           <a:p>
             <a:pPr lvl="3"/>
             <a:r>
-              <a:rPr lang="en-US" smtClean="0"/>
+              <a:rPr lang="en-US"/>
               <a:t>Fourth level</a:t>
             </a:r>
           </a:p>
           <a:p>
             <a:pPr lvl="4"/>
             <a:r>
-              <a:rPr lang="en-US" smtClean="0"/>
+              <a:rPr lang="en-US"/>
               <a:t>Fifth level</a:t>
             </a:r>
-            <a:endParaRPr lang="en-US"/>
           </a:p>
         </p:txBody>
       </p:sp>
@@ -468,7 +480,7 @@
           <a:p>
             <a:fld id="{5BCAD085-E8A6-8845-BD4E-CB4CCA059FC4}" type="datetimeFigureOut">
               <a:rPr lang="en-US" smtClean="0"/>
-              <a:t>1/27/13</a:t>
+              <a:t>9/23/2026</a:t>
             </a:fld>
             <a:endParaRPr lang="en-US"/>
           </a:p>
@@ -567,10 +579,9 @@
           <a:lstStyle/>
           <a:p>
             <a:r>
-              <a:rPr lang="en-US" smtClean="0"/>
+              <a:rPr lang="en-US"/>
               <a:t>Click to edit Master title style</a:t>
             </a:r>
-            <a:endParaRPr lang="en-US"/>
           </a:p>
         </p:txBody>
       </p:sp>
@@ -596,38 +607,37 @@
           <a:p>
             <a:pPr lvl="0"/>
             <a:r>
-              <a:rPr lang="en-US" smtClean="0"/>
+              <a:rPr lang="en-US"/>
               <a:t>Click to edit Master text styles</a:t>
             </a:r>
           </a:p>
           <a:p>
             <a:pPr lvl="1"/>
             <a:r>
-              <a:rPr lang="en-US" smtClean="0"/>
+              <a:rPr lang="en-US"/>
               <a:t>Second level</a:t>
             </a:r>
           </a:p>
           <a:p>
             <a:pPr lvl="2"/>
             <a:r>
-              <a:rPr lang="en-US" smtClean="0"/>
+              <a:rPr lang="en-US"/>
               <a:t>Third level</a:t>
             </a:r>
           </a:p>
           <a:p>
             <a:pPr lvl="3"/>
             <a:r>
-              <a:rPr lang="en-US" smtClean="0"/>
+              <a:rPr lang="en-US"/>
               <a:t>Fourth level</a:t>
             </a:r>
           </a:p>
           <a:p>
             <a:pPr lvl="4"/>
             <a:r>
-              <a:rPr lang="en-US" smtClean="0"/>
+              <a:rPr lang="en-US"/>
               <a:t>Fifth level</a:t>
             </a:r>
-            <a:endParaRPr lang="en-US"/>
           </a:p>
         </p:txBody>
       </p:sp>
@@ -648,7 +658,7 @@
           <a:p>
             <a:fld id="{5BCAD085-E8A6-8845-BD4E-CB4CCA059FC4}" type="datetimeFigureOut">
               <a:rPr lang="en-US" smtClean="0"/>
-              <a:t>1/27/13</a:t>
+              <a:t>9/23/2026</a:t>
             </a:fld>
             <a:endParaRPr lang="en-US"/>
           </a:p>
@@ -742,10 +752,9 @@
           <a:lstStyle/>
           <a:p>
             <a:r>
-              <a:rPr lang="en-US" smtClean="0"/>
+              <a:rPr lang="en-US"/>
               <a:t>Click to edit Master title style</a:t>
             </a:r>
-            <a:endParaRPr lang="en-US"/>
           </a:p>
         </p:txBody>
       </p:sp>
@@ -766,38 +775,37 @@
           <a:p>
             <a:pPr lvl="0"/>
             <a:r>
-              <a:rPr lang="en-US" smtClean="0"/>
+              <a:rPr lang="en-US"/>
               <a:t>Click to edit Master text styles</a:t>
             </a:r>
           </a:p>
           <a:p>
             <a:pPr lvl="1"/>
             <a:r>
-              <a:rPr lang="en-US" smtClean="0"/>
+              <a:rPr lang="en-US"/>
               <a:t>Second level</a:t>
             </a:r>
           </a:p>
           <a:p>
             <a:pPr lvl="2"/>
             <a:r>
-              <a:rPr lang="en-US" smtClean="0"/>
+              <a:rPr lang="en-US"/>
               <a:t>Third level</a:t>
             </a:r>
           </a:p>
           <a:p>
             <a:pPr lvl="3"/>
             <a:r>
-              <a:rPr lang="en-US" smtClean="0"/>
+              <a:rPr lang="en-US"/>
               <a:t>Fourth level</a:t>
             </a:r>
           </a:p>
           <a:p>
             <a:pPr lvl="4"/>
             <a:r>
-              <a:rPr lang="en-US" smtClean="0"/>
+              <a:rPr lang="en-US"/>
               <a:t>Fifth level</a:t>
             </a:r>
-            <a:endParaRPr lang="en-US"/>
           </a:p>
         </p:txBody>
       </p:sp>
@@ -818,7 +826,7 @@
           <a:p>
             <a:fld id="{5BCAD085-E8A6-8845-BD4E-CB4CCA059FC4}" type="datetimeFigureOut">
               <a:rPr lang="en-US" smtClean="0"/>
-              <a:t>1/27/13</a:t>
+              <a:t>9/23/2026</a:t>
             </a:fld>
             <a:endParaRPr lang="en-US"/>
           </a:p>
@@ -921,10 +929,9 @@
           </a:lstStyle>
           <a:p>
             <a:r>
-              <a:rPr lang="en-US" smtClean="0"/>
+              <a:rPr lang="en-US"/>
               <a:t>Click to edit Master title style</a:t>
             </a:r>
-            <a:endParaRPr lang="en-US"/>
           </a:p>
         </p:txBody>
       </p:sp>
@@ -1041,7 +1048,7 @@
           <a:p>
             <a:pPr lvl="0"/>
             <a:r>
-              <a:rPr lang="en-US" smtClean="0"/>
+              <a:rPr lang="en-US"/>
               <a:t>Click to edit Master text styles</a:t>
             </a:r>
           </a:p>
@@ -1064,7 +1071,7 @@
           <a:p>
             <a:fld id="{5BCAD085-E8A6-8845-BD4E-CB4CCA059FC4}" type="datetimeFigureOut">
               <a:rPr lang="en-US" smtClean="0"/>
-              <a:t>1/27/13</a:t>
+              <a:t>9/23/2026</a:t>
             </a:fld>
             <a:endParaRPr lang="en-US"/>
           </a:p>
@@ -1158,10 +1165,9 @@
           <a:lstStyle/>
           <a:p>
             <a:r>
-              <a:rPr lang="en-US" smtClean="0"/>
+              <a:rPr lang="en-US"/>
               <a:t>Click to edit Master title style</a:t>
             </a:r>
-            <a:endParaRPr lang="en-US"/>
           </a:p>
         </p:txBody>
       </p:sp>
@@ -1215,38 +1221,37 @@
           <a:p>
             <a:pPr lvl="0"/>
             <a:r>
-              <a:rPr lang="en-US" smtClean="0"/>
+              <a:rPr lang="en-US"/>
               <a:t>Click to edit Master text styles</a:t>
             </a:r>
           </a:p>
           <a:p>
             <a:pPr lvl="1"/>
             <a:r>
-              <a:rPr lang="en-US" smtClean="0"/>
+              <a:rPr lang="en-US"/>
               <a:t>Second level</a:t>
             </a:r>
           </a:p>
           <a:p>
             <a:pPr lvl="2"/>
             <a:r>
-              <a:rPr lang="en-US" smtClean="0"/>
+              <a:rPr lang="en-US"/>
               <a:t>Third level</a:t>
             </a:r>
           </a:p>
           <a:p>
             <a:pPr lvl="3"/>
             <a:r>
-              <a:rPr lang="en-US" smtClean="0"/>
+              <a:rPr lang="en-US"/>
               <a:t>Fourth level</a:t>
             </a:r>
           </a:p>
           <a:p>
             <a:pPr lvl="4"/>
             <a:r>
-              <a:rPr lang="en-US" smtClean="0"/>
+              <a:rPr lang="en-US"/>
               <a:t>Fifth level</a:t>
             </a:r>
-            <a:endParaRPr lang="en-US"/>
           </a:p>
         </p:txBody>
       </p:sp>
@@ -1300,38 +1305,37 @@
           <a:p>
             <a:pPr lvl="0"/>
             <a:r>
-              <a:rPr lang="en-US" smtClean="0"/>
+              <a:rPr lang="en-US"/>
               <a:t>Click to edit Master text styles</a:t>
             </a:r>
           </a:p>
           <a:p>
             <a:pPr lvl="1"/>
             <a:r>
-              <a:rPr lang="en-US" smtClean="0"/>
+              <a:rPr lang="en-US"/>
               <a:t>Second level</a:t>
             </a:r>
           </a:p>
           <a:p>
             <a:pPr lvl="2"/>
             <a:r>
-              <a:rPr lang="en-US" smtClean="0"/>
+              <a:rPr lang="en-US"/>
               <a:t>Third level</a:t>
             </a:r>
           </a:p>
           <a:p>
             <a:pPr lvl="3"/>
             <a:r>
-              <a:rPr lang="en-US" smtClean="0"/>
+              <a:rPr lang="en-US"/>
               <a:t>Fourth level</a:t>
             </a:r>
           </a:p>
           <a:p>
             <a:pPr lvl="4"/>
             <a:r>
-              <a:rPr lang="en-US" smtClean="0"/>
+              <a:rPr lang="en-US"/>
               <a:t>Fifth level</a:t>
             </a:r>
-            <a:endParaRPr lang="en-US"/>
           </a:p>
         </p:txBody>
       </p:sp>
@@ -1352,7 +1356,7 @@
           <a:p>
             <a:fld id="{5BCAD085-E8A6-8845-BD4E-CB4CCA059FC4}" type="datetimeFigureOut">
               <a:rPr lang="en-US" smtClean="0"/>
-              <a:t>1/27/13</a:t>
+              <a:t>9/23/2026</a:t>
             </a:fld>
             <a:endParaRPr lang="en-US"/>
           </a:p>
@@ -1450,10 +1454,9 @@
           </a:lstStyle>
           <a:p>
             <a:r>
-              <a:rPr lang="en-US" smtClean="0"/>
+              <a:rPr lang="en-US"/>
               <a:t>Click to edit Master title style</a:t>
             </a:r>
-            <a:endParaRPr lang="en-US"/>
           </a:p>
         </p:txBody>
       </p:sp>
@@ -1516,7 +1519,7 @@
           <a:p>
             <a:pPr lvl="0"/>
             <a:r>
-              <a:rPr lang="en-US" smtClean="0"/>
+              <a:rPr lang="en-US"/>
               <a:t>Click to edit Master text styles</a:t>
             </a:r>
           </a:p>
@@ -1572,38 +1575,37 @@
           <a:p>
             <a:pPr lvl="0"/>
             <a:r>
-              <a:rPr lang="en-US" smtClean="0"/>
+              <a:rPr lang="en-US"/>
               <a:t>Click to edit Master text styles</a:t>
             </a:r>
           </a:p>
           <a:p>
             <a:pPr lvl="1"/>
             <a:r>
-              <a:rPr lang="en-US" smtClean="0"/>
+              <a:rPr lang="en-US"/>
               <a:t>Second level</a:t>
             </a:r>
           </a:p>
           <a:p>
             <a:pPr lvl="2"/>
             <a:r>
-              <a:rPr lang="en-US" smtClean="0"/>
+              <a:rPr lang="en-US"/>
               <a:t>Third level</a:t>
             </a:r>
           </a:p>
           <a:p>
             <a:pPr lvl="3"/>
             <a:r>
-              <a:rPr lang="en-US" smtClean="0"/>
+              <a:rPr lang="en-US"/>
               <a:t>Fourth level</a:t>
             </a:r>
           </a:p>
           <a:p>
             <a:pPr lvl="4"/>
             <a:r>
-              <a:rPr lang="en-US" smtClean="0"/>
+              <a:rPr lang="en-US"/>
               <a:t>Fifth level</a:t>
             </a:r>
-            <a:endParaRPr lang="en-US"/>
           </a:p>
         </p:txBody>
       </p:sp>
@@ -1666,7 +1668,7 @@
           <a:p>
             <a:pPr lvl="0"/>
             <a:r>
-              <a:rPr lang="en-US" smtClean="0"/>
+              <a:rPr lang="en-US"/>
               <a:t>Click to edit Master text styles</a:t>
             </a:r>
           </a:p>
@@ -1722,38 +1724,37 @@
           <a:p>
             <a:pPr lvl="0"/>
             <a:r>
-              <a:rPr lang="en-US" smtClean="0"/>
+              <a:rPr lang="en-US"/>
               <a:t>Click to edit Master text styles</a:t>
             </a:r>
           </a:p>
           <a:p>
             <a:pPr lvl="1"/>
             <a:r>
-              <a:rPr lang="en-US" smtClean="0"/>
+              <a:rPr lang="en-US"/>
               <a:t>Second level</a:t>
             </a:r>
           </a:p>
           <a:p>
             <a:pPr lvl="2"/>
             <a:r>
-              <a:rPr lang="en-US" smtClean="0"/>
+              <a:rPr lang="en-US"/>
               <a:t>Third level</a:t>
             </a:r>
           </a:p>
           <a:p>
             <a:pPr lvl="3"/>
             <a:r>
-              <a:rPr lang="en-US" smtClean="0"/>
+              <a:rPr lang="en-US"/>
               <a:t>Fourth level</a:t>
             </a:r>
           </a:p>
           <a:p>
             <a:pPr lvl="4"/>
             <a:r>
-              <a:rPr lang="en-US" smtClean="0"/>
+              <a:rPr lang="en-US"/>
               <a:t>Fifth level</a:t>
             </a:r>
-            <a:endParaRPr lang="en-US"/>
           </a:p>
         </p:txBody>
       </p:sp>
@@ -1774,7 +1775,7 @@
           <a:p>
             <a:fld id="{5BCAD085-E8A6-8845-BD4E-CB4CCA059FC4}" type="datetimeFigureOut">
               <a:rPr lang="en-US" smtClean="0"/>
-              <a:t>1/27/13</a:t>
+              <a:t>9/23/2026</a:t>
             </a:fld>
             <a:endParaRPr lang="en-US"/>
           </a:p>
@@ -1868,10 +1869,9 @@
           <a:lstStyle/>
           <a:p>
             <a:r>
-              <a:rPr lang="en-US" smtClean="0"/>
+              <a:rPr lang="en-US"/>
               <a:t>Click to edit Master title style</a:t>
             </a:r>
-            <a:endParaRPr lang="en-US"/>
           </a:p>
         </p:txBody>
       </p:sp>
@@ -1892,7 +1892,7 @@
           <a:p>
             <a:fld id="{5BCAD085-E8A6-8845-BD4E-CB4CCA059FC4}" type="datetimeFigureOut">
               <a:rPr lang="en-US" smtClean="0"/>
-              <a:t>1/27/13</a:t>
+              <a:t>9/23/2026</a:t>
             </a:fld>
             <a:endParaRPr lang="en-US"/>
           </a:p>
@@ -1987,7 +1987,7 @@
           <a:p>
             <a:fld id="{5BCAD085-E8A6-8845-BD4E-CB4CCA059FC4}" type="datetimeFigureOut">
               <a:rPr lang="en-US" smtClean="0"/>
-              <a:t>1/27/13</a:t>
+              <a:t>9/23/2026</a:t>
             </a:fld>
             <a:endParaRPr lang="en-US"/>
           </a:p>
@@ -2090,10 +2090,9 @@
           </a:lstStyle>
           <a:p>
             <a:r>
-              <a:rPr lang="en-US" smtClean="0"/>
+              <a:rPr lang="en-US"/>
               <a:t>Click to edit Master title style</a:t>
             </a:r>
-            <a:endParaRPr lang="en-US"/>
           </a:p>
         </p:txBody>
       </p:sp>
@@ -2147,38 +2146,37 @@
           <a:p>
             <a:pPr lvl="0"/>
             <a:r>
-              <a:rPr lang="en-US" smtClean="0"/>
+              <a:rPr lang="en-US"/>
               <a:t>Click to edit Master text styles</a:t>
             </a:r>
           </a:p>
           <a:p>
             <a:pPr lvl="1"/>
             <a:r>
-              <a:rPr lang="en-US" smtClean="0"/>
+              <a:rPr lang="en-US"/>
               <a:t>Second level</a:t>
             </a:r>
           </a:p>
           <a:p>
             <a:pPr lvl="2"/>
             <a:r>
-              <a:rPr lang="en-US" smtClean="0"/>
+              <a:rPr lang="en-US"/>
               <a:t>Third level</a:t>
             </a:r>
           </a:p>
           <a:p>
             <a:pPr lvl="3"/>
             <a:r>
-              <a:rPr lang="en-US" smtClean="0"/>
+              <a:rPr lang="en-US"/>
               <a:t>Fourth level</a:t>
             </a:r>
           </a:p>
           <a:p>
             <a:pPr lvl="4"/>
             <a:r>
-              <a:rPr lang="en-US" smtClean="0"/>
+              <a:rPr lang="en-US"/>
               <a:t>Fifth level</a:t>
             </a:r>
-            <a:endParaRPr lang="en-US"/>
           </a:p>
         </p:txBody>
       </p:sp>
@@ -2241,7 +2239,7 @@
           <a:p>
             <a:pPr lvl="0"/>
             <a:r>
-              <a:rPr lang="en-US" smtClean="0"/>
+              <a:rPr lang="en-US"/>
               <a:t>Click to edit Master text styles</a:t>
             </a:r>
           </a:p>
@@ -2264,7 +2262,7 @@
           <a:p>
             <a:fld id="{5BCAD085-E8A6-8845-BD4E-CB4CCA059FC4}" type="datetimeFigureOut">
               <a:rPr lang="en-US" smtClean="0"/>
-              <a:t>1/27/13</a:t>
+              <a:t>9/23/2026</a:t>
             </a:fld>
             <a:endParaRPr lang="en-US"/>
           </a:p>
@@ -2367,10 +2365,9 @@
           </a:lstStyle>
           <a:p>
             <a:r>
-              <a:rPr lang="en-US" smtClean="0"/>
+              <a:rPr lang="en-US"/>
               <a:t>Click to edit Master title style</a:t>
             </a:r>
-            <a:endParaRPr lang="en-US"/>
           </a:p>
         </p:txBody>
       </p:sp>
@@ -2494,7 +2491,7 @@
           <a:p>
             <a:pPr lvl="0"/>
             <a:r>
-              <a:rPr lang="en-US" smtClean="0"/>
+              <a:rPr lang="en-US"/>
               <a:t>Click to edit Master text styles</a:t>
             </a:r>
           </a:p>
@@ -2517,7 +2514,7 @@
           <a:p>
             <a:fld id="{5BCAD085-E8A6-8845-BD4E-CB4CCA059FC4}" type="datetimeFigureOut">
               <a:rPr lang="en-US" smtClean="0"/>
-              <a:t>1/27/13</a:t>
+              <a:t>9/23/2026</a:t>
             </a:fld>
             <a:endParaRPr lang="en-US"/>
           </a:p>
@@ -2626,10 +2623,9 @@
           <a:lstStyle/>
           <a:p>
             <a:r>
-              <a:rPr lang="en-US" smtClean="0"/>
+              <a:rPr lang="en-US"/>
               <a:t>Click to edit Master title style</a:t>
             </a:r>
-            <a:endParaRPr lang="en-US"/>
           </a:p>
         </p:txBody>
       </p:sp>
@@ -2660,38 +2656,37 @@
           <a:p>
             <a:pPr lvl="0"/>
             <a:r>
-              <a:rPr lang="en-US" smtClean="0"/>
+              <a:rPr lang="en-US"/>
               <a:t>Click to edit Master text styles</a:t>
             </a:r>
           </a:p>
           <a:p>
             <a:pPr lvl="1"/>
             <a:r>
-              <a:rPr lang="en-US" smtClean="0"/>
+              <a:rPr lang="en-US"/>
               <a:t>Second level</a:t>
             </a:r>
           </a:p>
           <a:p>
             <a:pPr lvl="2"/>
             <a:r>
-              <a:rPr lang="en-US" smtClean="0"/>
+              <a:rPr lang="en-US"/>
               <a:t>Third level</a:t>
             </a:r>
           </a:p>
           <a:p>
             <a:pPr lvl="3"/>
             <a:r>
-              <a:rPr lang="en-US" smtClean="0"/>
+              <a:rPr lang="en-US"/>
               <a:t>Fourth level</a:t>
             </a:r>
           </a:p>
           <a:p>
             <a:pPr lvl="4"/>
             <a:r>
-              <a:rPr lang="en-US" smtClean="0"/>
+              <a:rPr lang="en-US"/>
               <a:t>Fifth level</a:t>
             </a:r>
-            <a:endParaRPr lang="en-US"/>
           </a:p>
         </p:txBody>
       </p:sp>
@@ -2730,7 +2725,7 @@
           <a:p>
             <a:fld id="{5BCAD085-E8A6-8845-BD4E-CB4CCA059FC4}" type="datetimeFigureOut">
               <a:rPr lang="en-US" smtClean="0"/>
-              <a:t>1/27/13</a:t>
+              <a:t>9/23/2026</a:t>
             </a:fld>
             <a:endParaRPr lang="en-US"/>
           </a:p>
@@ -3089,7 +3084,7 @@
 </file>
 
 <file path=ppt/slides/slide1.xml><?xml version="1.0" encoding="utf-8"?>
-<p:sld xmlns:a="http://schemas.openxmlformats.org/drawingml/2006/main" xmlns:p="http://schemas.openxmlformats.org/presentationml/2006/main" xmlns:r="http://schemas.openxmlformats.org/officeDocument/2006/relationships">
+<p:sld xmlns:a="http://schemas.openxmlformats.org/drawingml/2006/main" xmlns:r="http://schemas.openxmlformats.org/officeDocument/2006/relationships" xmlns:p="http://schemas.openxmlformats.org/presentationml/2006/main">
   <p:cSld>
     <p:spTree>
       <p:nvGrpSpPr>
@@ -3097,7 +3092,14 @@
         <p:cNvGrpSpPr/>
         <p:nvPr/>
       </p:nvGrpSpPr>
-      <p:grpSpPr/>
+      <p:grpSpPr>
+        <a:xfrm>
+          <a:off x="0" y="0"/>
+          <a:ext cx="0" cy="0"/>
+          <a:chOff x="0" y="0"/>
+          <a:chExt cx="0" cy="0"/>
+        </a:xfrm>
+      </p:grpSpPr>
       <p:sp>
         <p:nvSpPr>
           <p:cNvPr id="2" name="Rectangle 1"/>
@@ -3138,6 +3140,7 @@
           <a:lstStyle/>
           <a:p>
             <a:pPr algn="ctr"/>
+            <a:endParaRPr/>
           </a:p>
         </p:txBody>
       </p:sp>
@@ -3248,6 +3251,7 @@
           <a:lstStyle/>
           <a:p>
             <a:pPr algn="ctr"/>
+            <a:endParaRPr/>
           </a:p>
         </p:txBody>
       </p:sp>
@@ -3260,7 +3264,7 @@
         <p:spPr>
           <a:xfrm>
             <a:off x="1188720" y="4846320"/>
-            <a:ext cx="9784080" cy="1097280"/>
+            <a:ext cx="9784080" cy="825867"/>
           </a:xfrm>
           <a:prstGeom prst="rect">
             <a:avLst/>
@@ -3281,6 +3285,7 @@
               </a:defRPr>
             </a:pPr>
             <a:r>
+              <a:rPr dirty="0"/>
               <a:t>Author: Omar Khalil</a:t>
             </a:r>
           </a:p>
@@ -3296,6 +3301,7 @@
               </a:defRPr>
             </a:pPr>
             <a:r>
+              <a:rPr dirty="0"/>
               <a:t>GitHub Repository: https://github.com/OmarKhalil2003/Architectural-Styles-LoRA</a:t>
             </a:r>
           </a:p>
@@ -3311,7 +3317,16 @@
               </a:defRPr>
             </a:pPr>
             <a:r>
-              <a:t>Contact: omarkhalil.contact@gmail.com  |  Self-Directed Research Pilot</a:t>
+              <a:rPr dirty="0"/>
+              <a:t>Contact: o</a:t>
+            </a:r>
+            <a:r>
+              <a:rPr lang="en-GB" dirty="0"/>
+              <a:t>mark8977</a:t>
+            </a:r>
+            <a:r>
+              <a:rPr dirty="0"/>
+              <a:t>@gmail.com </a:t>
             </a:r>
           </a:p>
         </p:txBody>
@@ -3325,7 +3340,7 @@
 </file>
 
 <file path=ppt/slides/slide10.xml><?xml version="1.0" encoding="utf-8"?>
-<p:sld xmlns:a="http://schemas.openxmlformats.org/drawingml/2006/main" xmlns:p="http://schemas.openxmlformats.org/presentationml/2006/main" xmlns:r="http://schemas.openxmlformats.org/officeDocument/2006/relationships">
+<p:sld xmlns:a="http://schemas.openxmlformats.org/drawingml/2006/main" xmlns:r="http://schemas.openxmlformats.org/officeDocument/2006/relationships" xmlns:p="http://schemas.openxmlformats.org/presentationml/2006/main">
   <p:cSld>
     <p:spTree>
       <p:nvGrpSpPr>
@@ -3333,7 +3348,14 @@
         <p:cNvGrpSpPr/>
         <p:nvPr/>
       </p:nvGrpSpPr>
-      <p:grpSpPr/>
+      <p:grpSpPr>
+        <a:xfrm>
+          <a:off x="0" y="0"/>
+          <a:ext cx="0" cy="0"/>
+          <a:chOff x="0" y="0"/>
+          <a:chExt cx="0" cy="0"/>
+        </a:xfrm>
+      </p:grpSpPr>
       <p:sp>
         <p:nvSpPr>
           <p:cNvPr id="2" name="Rectangle 1"/>
@@ -3374,6 +3396,7 @@
           <a:lstStyle/>
           <a:p>
             <a:pPr algn="ctr"/>
+            <a:endParaRPr/>
           </a:p>
         </p:txBody>
       </p:sp>
@@ -3466,6 +3489,7 @@
           <a:lstStyle/>
           <a:p>
             <a:pPr algn="ctr"/>
+            <a:endParaRPr/>
           </a:p>
         </p:txBody>
       </p:sp>
@@ -3532,7 +3556,7 @@
               </a:spcBef>
             </a:pPr>
             <a:r>
-              <a:rPr b="1" sz="1300">
+              <a:rPr sz="1300" b="1">
                 <a:solidFill>
                   <a:srgbClr val="F5F7FA"/>
                 </a:solidFill>
@@ -3555,7 +3579,7 @@
               </a:spcBef>
             </a:pPr>
             <a:r>
-              <a:rPr b="1" sz="1300">
+              <a:rPr sz="1300" b="1">
                 <a:solidFill>
                   <a:srgbClr val="F5F7FA"/>
                 </a:solidFill>
@@ -3578,7 +3602,7 @@
               </a:spcBef>
             </a:pPr>
             <a:r>
-              <a:rPr b="1" sz="1300">
+              <a:rPr sz="1300" b="1">
                 <a:solidFill>
                   <a:srgbClr val="F5F7FA"/>
                 </a:solidFill>
@@ -3601,7 +3625,7 @@
               </a:spcBef>
             </a:pPr>
             <a:r>
-              <a:rPr b="1" sz="1300">
+              <a:rPr sz="1300" b="1">
                 <a:solidFill>
                   <a:srgbClr val="F5F7FA"/>
                 </a:solidFill>
@@ -3661,6 +3685,7 @@
           <a:lstStyle/>
           <a:p>
             <a:pPr algn="ctr"/>
+            <a:endParaRPr/>
           </a:p>
         </p:txBody>
       </p:sp>
@@ -3878,7 +3903,7 @@
 </file>
 
 <file path=ppt/slides/slide11.xml><?xml version="1.0" encoding="utf-8"?>
-<p:sld xmlns:a="http://schemas.openxmlformats.org/drawingml/2006/main" xmlns:p="http://schemas.openxmlformats.org/presentationml/2006/main" xmlns:r="http://schemas.openxmlformats.org/officeDocument/2006/relationships">
+<p:sld xmlns:a="http://schemas.openxmlformats.org/drawingml/2006/main" xmlns:r="http://schemas.openxmlformats.org/officeDocument/2006/relationships" xmlns:p="http://schemas.openxmlformats.org/presentationml/2006/main">
   <p:cSld>
     <p:spTree>
       <p:nvGrpSpPr>
@@ -3886,7 +3911,14 @@
         <p:cNvGrpSpPr/>
         <p:nvPr/>
       </p:nvGrpSpPr>
-      <p:grpSpPr/>
+      <p:grpSpPr>
+        <a:xfrm>
+          <a:off x="0" y="0"/>
+          <a:ext cx="0" cy="0"/>
+          <a:chOff x="0" y="0"/>
+          <a:chExt cx="0" cy="0"/>
+        </a:xfrm>
+      </p:grpSpPr>
       <p:sp>
         <p:nvSpPr>
           <p:cNvPr id="2" name="Rectangle 1"/>
@@ -3927,6 +3959,7 @@
           <a:lstStyle/>
           <a:p>
             <a:pPr algn="ctr"/>
+            <a:endParaRPr/>
           </a:p>
         </p:txBody>
       </p:sp>
@@ -4019,6 +4052,7 @@
           <a:lstStyle/>
           <a:p>
             <a:pPr algn="ctr"/>
+            <a:endParaRPr/>
           </a:p>
         </p:txBody>
       </p:sp>
@@ -4085,7 +4119,7 @@
               </a:spcBef>
             </a:pPr>
             <a:r>
-              <a:rPr b="1" sz="1200">
+              <a:rPr sz="1200" b="1">
                 <a:solidFill>
                   <a:srgbClr val="F5F7FA"/>
                 </a:solidFill>
@@ -4108,7 +4142,7 @@
               </a:spcBef>
             </a:pPr>
             <a:r>
-              <a:rPr b="1" sz="1200">
+              <a:rPr sz="1200" b="1">
                 <a:solidFill>
                   <a:srgbClr val="F5F7FA"/>
                 </a:solidFill>
@@ -4131,7 +4165,7 @@
               </a:spcBef>
             </a:pPr>
             <a:r>
-              <a:rPr b="1" sz="1200">
+              <a:rPr sz="1200" b="1">
                 <a:solidFill>
                   <a:srgbClr val="F5F7FA"/>
                 </a:solidFill>
@@ -4154,7 +4188,7 @@
               </a:spcBef>
             </a:pPr>
             <a:r>
-              <a:rPr b="1" sz="1200">
+              <a:rPr sz="1200" b="1">
                 <a:solidFill>
                   <a:srgbClr val="F5F7FA"/>
                 </a:solidFill>
@@ -4177,7 +4211,7 @@
               </a:spcBef>
             </a:pPr>
             <a:r>
-              <a:rPr b="1" sz="1200">
+              <a:rPr sz="1200" b="1">
                 <a:solidFill>
                   <a:srgbClr val="F5F7FA"/>
                 </a:solidFill>
@@ -4200,7 +4234,7 @@
               </a:spcBef>
             </a:pPr>
             <a:r>
-              <a:rPr b="1" sz="1200">
+              <a:rPr sz="1200" b="1">
                 <a:solidFill>
                   <a:srgbClr val="F5F7FA"/>
                 </a:solidFill>
@@ -4223,7 +4257,7 @@
               </a:spcBef>
             </a:pPr>
             <a:r>
-              <a:rPr b="1" sz="1200">
+              <a:rPr sz="1200" b="1">
                 <a:solidFill>
                   <a:srgbClr val="F5F7FA"/>
                 </a:solidFill>
@@ -4283,6 +4317,7 @@
           <a:lstStyle/>
           <a:p>
             <a:pPr algn="ctr"/>
+            <a:endParaRPr/>
           </a:p>
         </p:txBody>
       </p:sp>
@@ -4349,7 +4384,7 @@
               </a:spcBef>
             </a:pPr>
             <a:r>
-              <a:rPr b="1" sz="1200">
+              <a:rPr sz="1200" b="1">
                 <a:solidFill>
                   <a:srgbClr val="F5F7FA"/>
                 </a:solidFill>
@@ -4372,7 +4407,7 @@
               </a:spcBef>
             </a:pPr>
             <a:r>
-              <a:rPr b="1" sz="1200">
+              <a:rPr sz="1200" b="1">
                 <a:solidFill>
                   <a:srgbClr val="F5F7FA"/>
                 </a:solidFill>
@@ -4395,7 +4430,7 @@
               </a:spcBef>
             </a:pPr>
             <a:r>
-              <a:rPr b="1" sz="1200">
+              <a:rPr sz="1200" b="1">
                 <a:solidFill>
                   <a:srgbClr val="F5F7FA"/>
                 </a:solidFill>
@@ -4418,7 +4453,7 @@
               </a:spcBef>
             </a:pPr>
             <a:r>
-              <a:rPr b="1" sz="1200">
+              <a:rPr sz="1200" b="1">
                 <a:solidFill>
                   <a:srgbClr val="F5F7FA"/>
                 </a:solidFill>
@@ -4441,7 +4476,7 @@
               </a:spcBef>
             </a:pPr>
             <a:r>
-              <a:rPr b="1" sz="1200">
+              <a:rPr sz="1200" b="1">
                 <a:solidFill>
                   <a:srgbClr val="F5F7FA"/>
                 </a:solidFill>
@@ -4464,7 +4499,7 @@
               </a:spcBef>
             </a:pPr>
             <a:r>
-              <a:rPr b="1" sz="1200">
+              <a:rPr sz="1200" b="1">
                 <a:solidFill>
                   <a:srgbClr val="F5F7FA"/>
                 </a:solidFill>
@@ -4487,7 +4522,7 @@
               </a:spcBef>
             </a:pPr>
             <a:r>
-              <a:rPr b="1" sz="1200">
+              <a:rPr sz="1200" b="1">
                 <a:solidFill>
                   <a:srgbClr val="F5F7FA"/>
                 </a:solidFill>
@@ -4514,7 +4549,7 @@
 </file>
 
 <file path=ppt/slides/slide2.xml><?xml version="1.0" encoding="utf-8"?>
-<p:sld xmlns:a="http://schemas.openxmlformats.org/drawingml/2006/main" xmlns:p="http://schemas.openxmlformats.org/presentationml/2006/main" xmlns:r="http://schemas.openxmlformats.org/officeDocument/2006/relationships">
+<p:sld xmlns:a="http://schemas.openxmlformats.org/drawingml/2006/main" xmlns:r="http://schemas.openxmlformats.org/officeDocument/2006/relationships" xmlns:p="http://schemas.openxmlformats.org/presentationml/2006/main">
   <p:cSld>
     <p:spTree>
       <p:nvGrpSpPr>
@@ -4522,7 +4557,14 @@
         <p:cNvGrpSpPr/>
         <p:nvPr/>
       </p:nvGrpSpPr>
-      <p:grpSpPr/>
+      <p:grpSpPr>
+        <a:xfrm>
+          <a:off x="0" y="0"/>
+          <a:ext cx="0" cy="0"/>
+          <a:chOff x="0" y="0"/>
+          <a:chExt cx="0" cy="0"/>
+        </a:xfrm>
+      </p:grpSpPr>
       <p:sp>
         <p:nvSpPr>
           <p:cNvPr id="2" name="Rectangle 1"/>
@@ -4563,6 +4605,7 @@
           <a:lstStyle/>
           <a:p>
             <a:pPr algn="ctr"/>
+            <a:endParaRPr/>
           </a:p>
         </p:txBody>
       </p:sp>
@@ -4655,6 +4698,7 @@
           <a:lstStyle/>
           <a:p>
             <a:pPr algn="ctr"/>
+            <a:endParaRPr/>
           </a:p>
         </p:txBody>
       </p:sp>
@@ -4721,7 +4765,7 @@
               </a:spcBef>
             </a:pPr>
             <a:r>
-              <a:rPr b="1" sz="1300">
+              <a:rPr sz="1300" b="1">
                 <a:solidFill>
                   <a:srgbClr val="F5F7FA"/>
                 </a:solidFill>
@@ -4744,7 +4788,7 @@
               </a:spcBef>
             </a:pPr>
             <a:r>
-              <a:rPr b="1" sz="1300">
+              <a:rPr sz="1300" b="1">
                 <a:solidFill>
                   <a:srgbClr val="F5F7FA"/>
                 </a:solidFill>
@@ -4767,7 +4811,7 @@
               </a:spcBef>
             </a:pPr>
             <a:r>
-              <a:rPr b="1" sz="1300">
+              <a:rPr sz="1300" b="1">
                 <a:solidFill>
                   <a:srgbClr val="F5F7FA"/>
                 </a:solidFill>
@@ -4790,7 +4834,7 @@
               </a:spcBef>
             </a:pPr>
             <a:r>
-              <a:rPr b="1" sz="1300">
+              <a:rPr sz="1300" b="1">
                 <a:solidFill>
                   <a:srgbClr val="F5F7FA"/>
                 </a:solidFill>
@@ -4850,6 +4894,7 @@
           <a:lstStyle/>
           <a:p>
             <a:pPr algn="ctr"/>
+            <a:endParaRPr/>
           </a:p>
         </p:txBody>
       </p:sp>
@@ -4916,7 +4961,7 @@
               </a:spcBef>
             </a:pPr>
             <a:r>
-              <a:rPr b="1" sz="1300">
+              <a:rPr sz="1300" b="1">
                 <a:solidFill>
                   <a:srgbClr val="F5F7FA"/>
                 </a:solidFill>
@@ -4939,7 +4984,7 @@
               </a:spcBef>
             </a:pPr>
             <a:r>
-              <a:rPr b="1" sz="1300">
+              <a:rPr sz="1300" b="1">
                 <a:solidFill>
                   <a:srgbClr val="F5F7FA"/>
                 </a:solidFill>
@@ -4962,7 +5007,7 @@
               </a:spcBef>
             </a:pPr>
             <a:r>
-              <a:rPr b="1" sz="1300">
+              <a:rPr sz="1300" b="1">
                 <a:solidFill>
                   <a:srgbClr val="F5F7FA"/>
                 </a:solidFill>
@@ -4985,7 +5030,7 @@
               </a:spcBef>
             </a:pPr>
             <a:r>
-              <a:rPr b="1" sz="1300">
+              <a:rPr sz="1300" b="1">
                 <a:solidFill>
                   <a:srgbClr val="F5F7FA"/>
                 </a:solidFill>
@@ -5012,7 +5057,7 @@
 </file>
 
 <file path=ppt/slides/slide3.xml><?xml version="1.0" encoding="utf-8"?>
-<p:sld xmlns:a="http://schemas.openxmlformats.org/drawingml/2006/main" xmlns:p="http://schemas.openxmlformats.org/presentationml/2006/main" xmlns:r="http://schemas.openxmlformats.org/officeDocument/2006/relationships">
+<p:sld xmlns:a="http://schemas.openxmlformats.org/drawingml/2006/main" xmlns:r="http://schemas.openxmlformats.org/officeDocument/2006/relationships" xmlns:p="http://schemas.openxmlformats.org/presentationml/2006/main">
   <p:cSld>
     <p:spTree>
       <p:nvGrpSpPr>
@@ -5020,7 +5065,14 @@
         <p:cNvGrpSpPr/>
         <p:nvPr/>
       </p:nvGrpSpPr>
-      <p:grpSpPr/>
+      <p:grpSpPr>
+        <a:xfrm>
+          <a:off x="0" y="0"/>
+          <a:ext cx="0" cy="0"/>
+          <a:chOff x="0" y="0"/>
+          <a:chExt cx="0" cy="0"/>
+        </a:xfrm>
+      </p:grpSpPr>
       <p:sp>
         <p:nvSpPr>
           <p:cNvPr id="2" name="Rectangle 1"/>
@@ -5061,6 +5113,7 @@
           <a:lstStyle/>
           <a:p>
             <a:pPr algn="ctr"/>
+            <a:endParaRPr/>
           </a:p>
         </p:txBody>
       </p:sp>
@@ -5153,6 +5206,7 @@
           <a:lstStyle/>
           <a:p>
             <a:pPr algn="ctr"/>
+            <a:endParaRPr/>
           </a:p>
         </p:txBody>
       </p:sp>
@@ -5260,6 +5314,7 @@
           <a:lstStyle/>
           <a:p>
             <a:pPr algn="ctr"/>
+            <a:endParaRPr/>
           </a:p>
         </p:txBody>
       </p:sp>
@@ -5367,6 +5422,7 @@
           <a:lstStyle/>
           <a:p>
             <a:pPr algn="ctr"/>
+            <a:endParaRPr/>
           </a:p>
         </p:txBody>
       </p:sp>
@@ -5474,6 +5530,7 @@
           <a:lstStyle/>
           <a:p>
             <a:pPr algn="ctr"/>
+            <a:endParaRPr/>
           </a:p>
         </p:txBody>
       </p:sp>
@@ -5540,7 +5597,7 @@
               </a:spcBef>
             </a:pPr>
             <a:r>
-              <a:rPr b="1" sz="1300">
+              <a:rPr sz="1300" b="1">
                 <a:solidFill>
                   <a:srgbClr val="E1B96E"/>
                 </a:solidFill>
@@ -5563,7 +5620,7 @@
               </a:spcBef>
             </a:pPr>
             <a:r>
-              <a:rPr b="1" sz="1300">
+              <a:rPr sz="1300" b="1">
                 <a:solidFill>
                   <a:srgbClr val="F5F7FA"/>
                 </a:solidFill>
@@ -5586,7 +5643,7 @@
               </a:spcBef>
             </a:pPr>
             <a:r>
-              <a:rPr b="1" sz="1300">
+              <a:rPr sz="1300" b="1">
                 <a:solidFill>
                   <a:srgbClr val="73C3EB"/>
                 </a:solidFill>
@@ -5609,7 +5666,7 @@
               </a:spcBef>
             </a:pPr>
             <a:r>
-              <a:rPr b="1" sz="1300">
+              <a:rPr sz="1300" b="1">
                 <a:solidFill>
                   <a:srgbClr val="F5F7FA"/>
                 </a:solidFill>
@@ -5636,7 +5693,7 @@
 </file>
 
 <file path=ppt/slides/slide4.xml><?xml version="1.0" encoding="utf-8"?>
-<p:sld xmlns:a="http://schemas.openxmlformats.org/drawingml/2006/main" xmlns:p="http://schemas.openxmlformats.org/presentationml/2006/main" xmlns:r="http://schemas.openxmlformats.org/officeDocument/2006/relationships">
+<p:sld xmlns:a="http://schemas.openxmlformats.org/drawingml/2006/main" xmlns:r="http://schemas.openxmlformats.org/officeDocument/2006/relationships" xmlns:p="http://schemas.openxmlformats.org/presentationml/2006/main">
   <p:cSld>
     <p:spTree>
       <p:nvGrpSpPr>
@@ -5644,7 +5701,14 @@
         <p:cNvGrpSpPr/>
         <p:nvPr/>
       </p:nvGrpSpPr>
-      <p:grpSpPr/>
+      <p:grpSpPr>
+        <a:xfrm>
+          <a:off x="0" y="0"/>
+          <a:ext cx="0" cy="0"/>
+          <a:chOff x="0" y="0"/>
+          <a:chExt cx="0" cy="0"/>
+        </a:xfrm>
+      </p:grpSpPr>
       <p:sp>
         <p:nvSpPr>
           <p:cNvPr id="2" name="Rectangle 1"/>
@@ -5685,6 +5749,7 @@
           <a:lstStyle/>
           <a:p>
             <a:pPr algn="ctr"/>
+            <a:endParaRPr/>
           </a:p>
         </p:txBody>
       </p:sp>
@@ -5777,6 +5842,7 @@
           <a:lstStyle/>
           <a:p>
             <a:pPr algn="ctr"/>
+            <a:endParaRPr/>
           </a:p>
         </p:txBody>
       </p:sp>
@@ -5843,7 +5909,7 @@
               </a:spcBef>
             </a:pPr>
             <a:r>
-              <a:rPr b="1" sz="1300">
+              <a:rPr sz="1300" b="1">
                 <a:solidFill>
                   <a:srgbClr val="F5F7FA"/>
                 </a:solidFill>
@@ -5866,7 +5932,7 @@
               </a:spcBef>
             </a:pPr>
             <a:r>
-              <a:rPr b="1" sz="1300">
+              <a:rPr sz="1300" b="1">
                 <a:solidFill>
                   <a:srgbClr val="F5F7FA"/>
                 </a:solidFill>
@@ -5889,7 +5955,7 @@
               </a:spcBef>
             </a:pPr>
             <a:r>
-              <a:rPr b="1" sz="1300">
+              <a:rPr sz="1300" b="1">
                 <a:solidFill>
                   <a:srgbClr val="F5F7FA"/>
                 </a:solidFill>
@@ -5912,7 +5978,7 @@
               </a:spcBef>
             </a:pPr>
             <a:r>
-              <a:rPr b="1" sz="1300">
+              <a:rPr sz="1300" b="1">
                 <a:solidFill>
                   <a:srgbClr val="F5F7FA"/>
                 </a:solidFill>
@@ -5972,6 +6038,7 @@
           <a:lstStyle/>
           <a:p>
             <a:pPr algn="ctr"/>
+            <a:endParaRPr/>
           </a:p>
         </p:txBody>
       </p:sp>
@@ -6038,7 +6105,7 @@
               </a:spcBef>
             </a:pPr>
             <a:r>
-              <a:rPr b="1" sz="1300">
+              <a:rPr sz="1300" b="1">
                 <a:solidFill>
                   <a:srgbClr val="F5F7FA"/>
                 </a:solidFill>
@@ -6061,7 +6128,7 @@
               </a:spcBef>
             </a:pPr>
             <a:r>
-              <a:rPr b="1" sz="1300">
+              <a:rPr sz="1300" b="1">
                 <a:solidFill>
                   <a:srgbClr val="F5F7FA"/>
                 </a:solidFill>
@@ -6084,7 +6151,7 @@
               </a:spcBef>
             </a:pPr>
             <a:r>
-              <a:rPr b="1" sz="1300">
+              <a:rPr sz="1300" b="1">
                 <a:solidFill>
                   <a:srgbClr val="F5F7FA"/>
                 </a:solidFill>
@@ -6107,7 +6174,7 @@
               </a:spcBef>
             </a:pPr>
             <a:r>
-              <a:rPr b="1" sz="1300">
+              <a:rPr sz="1300" b="1">
                 <a:solidFill>
                   <a:srgbClr val="F5F7FA"/>
                 </a:solidFill>
@@ -6134,7 +6201,7 @@
 </file>
 
 <file path=ppt/slides/slide5.xml><?xml version="1.0" encoding="utf-8"?>
-<p:sld xmlns:a="http://schemas.openxmlformats.org/drawingml/2006/main" xmlns:p="http://schemas.openxmlformats.org/presentationml/2006/main" xmlns:r="http://schemas.openxmlformats.org/officeDocument/2006/relationships">
+<p:sld xmlns:a="http://schemas.openxmlformats.org/drawingml/2006/main" xmlns:r="http://schemas.openxmlformats.org/officeDocument/2006/relationships" xmlns:p="http://schemas.openxmlformats.org/presentationml/2006/main">
   <p:cSld>
     <p:spTree>
       <p:nvGrpSpPr>
@@ -6142,7 +6209,14 @@
         <p:cNvGrpSpPr/>
         <p:nvPr/>
       </p:nvGrpSpPr>
-      <p:grpSpPr/>
+      <p:grpSpPr>
+        <a:xfrm>
+          <a:off x="0" y="0"/>
+          <a:ext cx="0" cy="0"/>
+          <a:chOff x="0" y="0"/>
+          <a:chExt cx="0" cy="0"/>
+        </a:xfrm>
+      </p:grpSpPr>
       <p:sp>
         <p:nvSpPr>
           <p:cNvPr id="2" name="Rectangle 1"/>
@@ -6183,6 +6257,7 @@
           <a:lstStyle/>
           <a:p>
             <a:pPr algn="ctr"/>
+            <a:endParaRPr/>
           </a:p>
         </p:txBody>
       </p:sp>
@@ -6275,6 +6350,7 @@
           <a:lstStyle/>
           <a:p>
             <a:pPr algn="ctr"/>
+            <a:endParaRPr/>
           </a:p>
         </p:txBody>
       </p:sp>
@@ -6341,7 +6417,7 @@
               </a:spcBef>
             </a:pPr>
             <a:r>
-              <a:rPr b="1" sz="1200">
+              <a:rPr sz="1200" b="1">
                 <a:solidFill>
                   <a:srgbClr val="73C3EB"/>
                 </a:solidFill>
@@ -6372,7 +6448,7 @@
               </a:spcBef>
             </a:pPr>
             <a:r>
-              <a:rPr b="1" sz="1200">
+              <a:rPr sz="1200" b="1">
                 <a:solidFill>
                   <a:srgbClr val="73C3EB"/>
                 </a:solidFill>
@@ -6403,7 +6479,7 @@
               </a:spcBef>
             </a:pPr>
             <a:r>
-              <a:rPr b="1" sz="1200">
+              <a:rPr sz="1200" b="1">
                 <a:solidFill>
                   <a:srgbClr val="73C3EB"/>
                 </a:solidFill>
@@ -6434,7 +6510,7 @@
               </a:spcBef>
             </a:pPr>
             <a:r>
-              <a:rPr b="1" sz="1200">
+              <a:rPr sz="1200" b="1">
                 <a:solidFill>
                   <a:srgbClr val="73C3EB"/>
                 </a:solidFill>
@@ -6465,7 +6541,7 @@
               </a:spcBef>
             </a:pPr>
             <a:r>
-              <a:rPr b="1" sz="1200">
+              <a:rPr sz="1200" b="1">
                 <a:solidFill>
                   <a:srgbClr val="73C3EB"/>
                 </a:solidFill>
@@ -6496,7 +6572,7 @@
               </a:spcBef>
             </a:pPr>
             <a:r>
-              <a:rPr b="1" sz="1200">
+              <a:rPr sz="1200" b="1">
                 <a:solidFill>
                   <a:srgbClr val="73C3EB"/>
                 </a:solidFill>
@@ -6527,7 +6603,7 @@
               </a:spcBef>
             </a:pPr>
             <a:r>
-              <a:rPr b="1" sz="1200">
+              <a:rPr sz="1200" b="1">
                 <a:solidFill>
                   <a:srgbClr val="73C3EB"/>
                 </a:solidFill>
@@ -6558,7 +6634,7 @@
               </a:spcBef>
             </a:pPr>
             <a:r>
-              <a:rPr b="1" sz="1200">
+              <a:rPr sz="1200" b="1">
                 <a:solidFill>
                   <a:srgbClr val="73C3EB"/>
                 </a:solidFill>
@@ -6593,7 +6669,7 @@
 </file>
 
 <file path=ppt/slides/slide6.xml><?xml version="1.0" encoding="utf-8"?>
-<p:sld xmlns:a="http://schemas.openxmlformats.org/drawingml/2006/main" xmlns:p="http://schemas.openxmlformats.org/presentationml/2006/main" xmlns:r="http://schemas.openxmlformats.org/officeDocument/2006/relationships">
+<p:sld xmlns:a="http://schemas.openxmlformats.org/drawingml/2006/main" xmlns:r="http://schemas.openxmlformats.org/officeDocument/2006/relationships" xmlns:p="http://schemas.openxmlformats.org/presentationml/2006/main">
   <p:cSld>
     <p:spTree>
       <p:nvGrpSpPr>
@@ -6601,7 +6677,14 @@
         <p:cNvGrpSpPr/>
         <p:nvPr/>
       </p:nvGrpSpPr>
-      <p:grpSpPr/>
+      <p:grpSpPr>
+        <a:xfrm>
+          <a:off x="0" y="0"/>
+          <a:ext cx="0" cy="0"/>
+          <a:chOff x="0" y="0"/>
+          <a:chExt cx="0" cy="0"/>
+        </a:xfrm>
+      </p:grpSpPr>
       <p:sp>
         <p:nvSpPr>
           <p:cNvPr id="2" name="Rectangle 1"/>
@@ -6642,6 +6725,7 @@
           <a:lstStyle/>
           <a:p>
             <a:pPr algn="ctr"/>
+            <a:endParaRPr/>
           </a:p>
         </p:txBody>
       </p:sp>
@@ -6734,6 +6818,7 @@
           <a:lstStyle/>
           <a:p>
             <a:pPr algn="ctr"/>
+            <a:endParaRPr/>
           </a:p>
         </p:txBody>
       </p:sp>
@@ -6800,7 +6885,7 @@
               </a:spcBef>
             </a:pPr>
             <a:r>
-              <a:rPr b="1" sz="1300">
+              <a:rPr sz="1300" b="1">
                 <a:solidFill>
                   <a:srgbClr val="F5F7FA"/>
                 </a:solidFill>
@@ -6823,7 +6908,7 @@
               </a:spcBef>
             </a:pPr>
             <a:r>
-              <a:rPr b="1" sz="1300">
+              <a:rPr sz="1300" b="1">
                 <a:solidFill>
                   <a:srgbClr val="F5F7FA"/>
                 </a:solidFill>
@@ -6846,7 +6931,7 @@
               </a:spcBef>
             </a:pPr>
             <a:r>
-              <a:rPr b="1" sz="1300">
+              <a:rPr sz="1300" b="1">
                 <a:solidFill>
                   <a:srgbClr val="F5F7FA"/>
                 </a:solidFill>
@@ -6869,7 +6954,7 @@
               </a:spcBef>
             </a:pPr>
             <a:r>
-              <a:rPr b="1" sz="1300">
+              <a:rPr sz="1300" b="1">
                 <a:solidFill>
                   <a:srgbClr val="F5F7FA"/>
                 </a:solidFill>
@@ -6929,6 +7014,7 @@
           <a:lstStyle/>
           <a:p>
             <a:pPr algn="ctr"/>
+            <a:endParaRPr/>
           </a:p>
         </p:txBody>
       </p:sp>
@@ -6995,7 +7081,7 @@
               </a:spcBef>
             </a:pPr>
             <a:r>
-              <a:rPr b="1" sz="1300">
+              <a:rPr sz="1300" b="1">
                 <a:solidFill>
                   <a:srgbClr val="E1B96E"/>
                 </a:solidFill>
@@ -7018,7 +7104,7 @@
               </a:spcBef>
             </a:pPr>
             <a:r>
-              <a:rPr b="1" sz="1300">
+              <a:rPr sz="1300" b="1">
                 <a:solidFill>
                   <a:srgbClr val="E1B96E"/>
                 </a:solidFill>
@@ -7041,7 +7127,7 @@
               </a:spcBef>
             </a:pPr>
             <a:r>
-              <a:rPr b="1" sz="1300">
+              <a:rPr sz="1300" b="1">
                 <a:solidFill>
                   <a:srgbClr val="E1B96E"/>
                 </a:solidFill>
@@ -7064,7 +7150,7 @@
               </a:spcBef>
             </a:pPr>
             <a:r>
-              <a:rPr b="1" sz="1300">
+              <a:rPr sz="1300" b="1">
                 <a:solidFill>
                   <a:srgbClr val="E1B96E"/>
                 </a:solidFill>
@@ -7091,7 +7177,7 @@
 </file>
 
 <file path=ppt/slides/slide7.xml><?xml version="1.0" encoding="utf-8"?>
-<p:sld xmlns:a="http://schemas.openxmlformats.org/drawingml/2006/main" xmlns:p="http://schemas.openxmlformats.org/presentationml/2006/main" xmlns:r="http://schemas.openxmlformats.org/officeDocument/2006/relationships">
+<p:sld xmlns:a="http://schemas.openxmlformats.org/drawingml/2006/main" xmlns:r="http://schemas.openxmlformats.org/officeDocument/2006/relationships" xmlns:p="http://schemas.openxmlformats.org/presentationml/2006/main">
   <p:cSld>
     <p:spTree>
       <p:nvGrpSpPr>
@@ -7099,7 +7185,14 @@
         <p:cNvGrpSpPr/>
         <p:nvPr/>
       </p:nvGrpSpPr>
-      <p:grpSpPr/>
+      <p:grpSpPr>
+        <a:xfrm>
+          <a:off x="0" y="0"/>
+          <a:ext cx="0" cy="0"/>
+          <a:chOff x="0" y="0"/>
+          <a:chExt cx="0" cy="0"/>
+        </a:xfrm>
+      </p:grpSpPr>
       <p:sp>
         <p:nvSpPr>
           <p:cNvPr id="2" name="Rectangle 1"/>
@@ -7140,6 +7233,7 @@
           <a:lstStyle/>
           <a:p>
             <a:pPr algn="ctr"/>
+            <a:endParaRPr/>
           </a:p>
         </p:txBody>
       </p:sp>
@@ -7232,6 +7326,7 @@
           <a:lstStyle/>
           <a:p>
             <a:pPr algn="ctr"/>
+            <a:endParaRPr/>
           </a:p>
         </p:txBody>
       </p:sp>
@@ -7298,7 +7393,7 @@
               </a:spcBef>
             </a:pPr>
             <a:r>
-              <a:rPr b="1" sz="1200">
+              <a:rPr sz="1200" b="1">
                 <a:solidFill>
                   <a:srgbClr val="F5F7FA"/>
                 </a:solidFill>
@@ -7314,7 +7409,7 @@
               <a:t>Stark angular roofline, planar concrete; no pointed arches observed  </a:t>
             </a:r>
             <a:r>
-              <a:rPr b="1" sz="1100">
+              <a:rPr sz="1100" b="1">
                 <a:solidFill>
                   <a:srgbClr val="87D79B"/>
                 </a:solidFill>
@@ -7329,7 +7424,7 @@
               </a:spcBef>
             </a:pPr>
             <a:r>
-              <a:rPr b="1" sz="1200">
+              <a:rPr sz="1200" b="1">
                 <a:solidFill>
                   <a:srgbClr val="F5F7FA"/>
                 </a:solidFill>
@@ -7345,7 +7440,7 @@
               <a:t>Cantilevered horizontal plates, rectangular piers; no pediments observed  </a:t>
             </a:r>
             <a:r>
-              <a:rPr b="1" sz="1100">
+              <a:rPr sz="1100" b="1">
                 <a:solidFill>
                   <a:srgbClr val="87D79B"/>
                 </a:solidFill>
@@ -7360,7 +7455,7 @@
               </a:spcBef>
             </a:pPr>
             <a:r>
-              <a:rPr b="1" sz="1200">
+              <a:rPr sz="1200" b="1">
                 <a:solidFill>
                   <a:srgbClr val="F5F7FA"/>
                 </a:solidFill>
@@ -7376,7 +7471,7 @@
               <a:t>Bush-hammered concrete, modular grid, gray palette; no pastels observed  </a:t>
             </a:r>
             <a:r>
-              <a:rPr b="1" sz="1100">
+              <a:rPr sz="1100" b="1">
                 <a:solidFill>
                   <a:srgbClr val="87D79B"/>
                 </a:solidFill>
@@ -7391,7 +7486,7 @@
               </a:spcBef>
             </a:pPr>
             <a:r>
-              <a:rPr b="1" sz="1200">
+              <a:rPr sz="1200" b="1">
                 <a:solidFill>
                   <a:srgbClr val="F5F7FA"/>
                 </a:solidFill>
@@ -7407,7 +7502,7 @@
               <a:t>Thick textured cast-in-place concrete; no thin steel curtain walls observed  </a:t>
             </a:r>
             <a:r>
-              <a:rPr b="1" sz="1100">
+              <a:rPr sz="1100" b="1">
                 <a:solidFill>
                   <a:srgbClr val="87D79B"/>
                 </a:solidFill>
@@ -7422,7 +7517,7 @@
               </a:spcBef>
             </a:pPr>
             <a:r>
-              <a:rPr b="1" sz="1200">
+              <a:rPr sz="1200" b="1">
                 <a:solidFill>
                   <a:srgbClr val="F5F7FA"/>
                 </a:solidFill>
@@ -7438,7 +7533,7 @@
               <a:t>Heavy shear walls dominate; narrow slit windows; no glass towers observed  </a:t>
             </a:r>
             <a:r>
-              <a:rPr b="1" sz="1100">
+              <a:rPr sz="1100" b="1">
                 <a:solidFill>
                   <a:srgbClr val="87D79B"/>
                 </a:solidFill>
@@ -7453,7 +7548,7 @@
               </a:spcBef>
             </a:pPr>
             <a:r>
-              <a:rPr b="1" sz="1200">
+              <a:rPr sz="1200" b="1">
                 <a:solidFill>
                   <a:srgbClr val="F5F7FA"/>
                 </a:solidFill>
@@ -7469,7 +7564,7 @@
               <a:t>Heavy rectangular cast concrete canopy portal; no organic curves observed  </a:t>
             </a:r>
             <a:r>
-              <a:rPr b="1" sz="1100">
+              <a:rPr sz="1100" b="1">
                 <a:solidFill>
                   <a:srgbClr val="87D79B"/>
                 </a:solidFill>
@@ -7484,7 +7579,7 @@
               </a:spcBef>
             </a:pPr>
             <a:r>
-              <a:rPr b="1" sz="1200">
+              <a:rPr sz="1200" b="1">
                 <a:solidFill>
                   <a:srgbClr val="F5F7FA"/>
                 </a:solidFill>
@@ -7500,7 +7595,7 @@
               <a:t>Unfinished gray concrete panels with form-tie holes; no slick finishes observed  </a:t>
             </a:r>
             <a:r>
-              <a:rPr b="1" sz="1100">
+              <a:rPr sz="1100" b="1">
                 <a:solidFill>
                   <a:srgbClr val="87D79B"/>
                 </a:solidFill>
@@ -7519,7 +7614,7 @@
 </file>
 
 <file path=ppt/slides/slide8.xml><?xml version="1.0" encoding="utf-8"?>
-<p:sld xmlns:a="http://schemas.openxmlformats.org/drawingml/2006/main" xmlns:p="http://schemas.openxmlformats.org/presentationml/2006/main" xmlns:r="http://schemas.openxmlformats.org/officeDocument/2006/relationships">
+<p:sld xmlns:a="http://schemas.openxmlformats.org/drawingml/2006/main" xmlns:r="http://schemas.openxmlformats.org/officeDocument/2006/relationships" xmlns:p="http://schemas.openxmlformats.org/presentationml/2006/main">
   <p:cSld>
     <p:spTree>
       <p:nvGrpSpPr>
@@ -7527,7 +7622,14 @@
         <p:cNvGrpSpPr/>
         <p:nvPr/>
       </p:nvGrpSpPr>
-      <p:grpSpPr/>
+      <p:grpSpPr>
+        <a:xfrm>
+          <a:off x="0" y="0"/>
+          <a:ext cx="0" cy="0"/>
+          <a:chOff x="0" y="0"/>
+          <a:chExt cx="0" cy="0"/>
+        </a:xfrm>
+      </p:grpSpPr>
       <p:sp>
         <p:nvSpPr>
           <p:cNvPr id="2" name="Rectangle 1"/>
@@ -7568,6 +7670,7 @@
           <a:lstStyle/>
           <a:p>
             <a:pPr algn="ctr"/>
+            <a:endParaRPr/>
           </a:p>
         </p:txBody>
       </p:sp>
@@ -7660,6 +7763,7 @@
           <a:lstStyle/>
           <a:p>
             <a:pPr algn="ctr"/>
+            <a:endParaRPr/>
           </a:p>
         </p:txBody>
       </p:sp>
@@ -7767,6 +7871,7 @@
           <a:lstStyle/>
           <a:p>
             <a:pPr algn="ctr"/>
+            <a:endParaRPr/>
           </a:p>
         </p:txBody>
       </p:sp>
@@ -7874,6 +7979,7 @@
           <a:lstStyle/>
           <a:p>
             <a:pPr algn="ctr"/>
+            <a:endParaRPr/>
           </a:p>
         </p:txBody>
       </p:sp>
@@ -7981,6 +8087,7 @@
           <a:lstStyle/>
           <a:p>
             <a:pPr algn="ctr"/>
+            <a:endParaRPr/>
           </a:p>
         </p:txBody>
       </p:sp>
@@ -8088,6 +8195,7 @@
           <a:lstStyle/>
           <a:p>
             <a:pPr algn="ctr"/>
+            <a:endParaRPr/>
           </a:p>
         </p:txBody>
       </p:sp>
@@ -8154,7 +8262,7 @@
               </a:spcBef>
             </a:pPr>
             <a:r>
-              <a:rPr b="1" sz="1300">
+              <a:rPr sz="1300" b="1">
                 <a:solidFill>
                   <a:srgbClr val="F5F7FA"/>
                 </a:solidFill>
@@ -8177,7 +8285,7 @@
               </a:spcBef>
             </a:pPr>
             <a:r>
-              <a:rPr b="1" sz="1300">
+              <a:rPr sz="1300" b="1">
                 <a:solidFill>
                   <a:srgbClr val="E1B96E"/>
                 </a:solidFill>
@@ -8200,7 +8308,7 @@
               </a:spcBef>
             </a:pPr>
             <a:r>
-              <a:rPr b="1" sz="1300">
+              <a:rPr sz="1300" b="1">
                 <a:solidFill>
                   <a:srgbClr val="F5F7FA"/>
                 </a:solidFill>
@@ -8227,7 +8335,7 @@
 </file>
 
 <file path=ppt/slides/slide9.xml><?xml version="1.0" encoding="utf-8"?>
-<p:sld xmlns:a="http://schemas.openxmlformats.org/drawingml/2006/main" xmlns:p="http://schemas.openxmlformats.org/presentationml/2006/main" xmlns:r="http://schemas.openxmlformats.org/officeDocument/2006/relationships">
+<p:sld xmlns:a="http://schemas.openxmlformats.org/drawingml/2006/main" xmlns:r="http://schemas.openxmlformats.org/officeDocument/2006/relationships" xmlns:p="http://schemas.openxmlformats.org/presentationml/2006/main">
   <p:cSld>
     <p:spTree>
       <p:nvGrpSpPr>
@@ -8235,7 +8343,14 @@
         <p:cNvGrpSpPr/>
         <p:nvPr/>
       </p:nvGrpSpPr>
-      <p:grpSpPr/>
+      <p:grpSpPr>
+        <a:xfrm>
+          <a:off x="0" y="0"/>
+          <a:ext cx="0" cy="0"/>
+          <a:chOff x="0" y="0"/>
+          <a:chExt cx="0" cy="0"/>
+        </a:xfrm>
+      </p:grpSpPr>
       <p:sp>
         <p:nvSpPr>
           <p:cNvPr id="2" name="Rectangle 1"/>
@@ -8276,6 +8391,7 @@
           <a:lstStyle/>
           <a:p>
             <a:pPr algn="ctr"/>
+            <a:endParaRPr/>
           </a:p>
         </p:txBody>
       </p:sp>
@@ -8368,6 +8484,7 @@
           <a:lstStyle/>
           <a:p>
             <a:pPr algn="ctr"/>
+            <a:endParaRPr/>
           </a:p>
         </p:txBody>
       </p:sp>
@@ -8461,7 +8578,7 @@
               </a:spcBef>
             </a:pPr>
             <a:r>
-              <a:rPr b="1" sz="1300">
+              <a:rPr sz="1300" b="1">
                 <a:solidFill>
                   <a:srgbClr val="F5F7FA"/>
                 </a:solidFill>
@@ -8484,7 +8601,7 @@
               </a:spcBef>
             </a:pPr>
             <a:r>
-              <a:rPr b="1" sz="1300">
+              <a:rPr sz="1300" b="1">
                 <a:solidFill>
                   <a:srgbClr val="F5F7FA"/>
                 </a:solidFill>
@@ -8507,7 +8624,7 @@
               </a:spcBef>
             </a:pPr>
             <a:r>
-              <a:rPr b="1" sz="1300">
+              <a:rPr sz="1300" b="1">
                 <a:solidFill>
                   <a:srgbClr val="F5F7FA"/>
                 </a:solidFill>
@@ -8530,7 +8647,7 @@
               </a:spcBef>
             </a:pPr>
             <a:r>
-              <a:rPr b="1" sz="1300">
+              <a:rPr sz="1300" b="1">
                 <a:solidFill>
                   <a:srgbClr val="F5F7FA"/>
                 </a:solidFill>

</xml_diff>